<commit_message>
ajout de paramettre de statistique sur l'utilisation des velos
</commit_message>
<xml_diff>
--- a/Velo en libre service/Etude_de_cas_cyclistic.pptx
+++ b/Velo en libre service/Etude_de_cas_cyclistic.pptx
@@ -6,6 +6,10 @@
   </p:sldMasterIdLst>
   <p:sldIdLst>
     <p:sldId id="256" r:id="rId2"/>
+    <p:sldId id="257" r:id="rId3"/>
+    <p:sldId id="258" r:id="rId4"/>
+    <p:sldId id="259" r:id="rId5"/>
+    <p:sldId id="260" r:id="rId6"/>
   </p:sldIdLst>
   <p:sldSz cx="12192000" cy="6858000"/>
   <p:notesSz cx="6858000" cy="9144000"/>
@@ -104,6 +108,11 @@
       </a:defRPr>
     </a:lvl9pPr>
   </p:defaultTextStyle>
+  <p:extLst>
+    <p:ext uri="{EFAFB233-063F-42B5-8137-9DF3F51BA10A}">
+      <p15:sldGuideLst xmlns:p15="http://schemas.microsoft.com/office/powerpoint/2012/main"/>
+    </p:ext>
+  </p:extLst>
 </p:presentation>
 </file>
 
@@ -3344,8 +3353,13 @@
           <a:p>
             <a:r>
               <a:rPr lang="fr-FR" dirty="0"/>
-              <a:t>Vélo en libre service</a:t>
-            </a:r>
+              <a:t>Vélo en libre service </a:t>
+            </a:r>
+            <a:r>
+              <a:rPr lang="fr-FR" dirty="0" err="1"/>
+              <a:t>Cyclistic</a:t>
+            </a:r>
+            <a:endParaRPr lang="fr-FR" dirty="0"/>
           </a:p>
         </p:txBody>
       </p:sp>
@@ -3377,7 +3391,7 @@
           </a:p>
           <a:p>
             <a:r>
-              <a:rPr lang="fr-FR"/>
+              <a:rPr lang="fr-FR" dirty="0"/>
               <a:t>Le 16 Mai 2026</a:t>
             </a:r>
           </a:p>
@@ -3387,6 +3401,326 @@
     <p:extLst>
       <p:ext uri="{BB962C8B-B14F-4D97-AF65-F5344CB8AC3E}">
         <p14:creationId xmlns:p14="http://schemas.microsoft.com/office/powerpoint/2010/main" val="3422585109"/>
+      </p:ext>
+    </p:extLst>
+  </p:cSld>
+  <p:clrMapOvr>
+    <a:masterClrMapping/>
+  </p:clrMapOvr>
+</p:sld>
+</file>
+
+<file path=ppt/slides/slide2.xml><?xml version="1.0" encoding="utf-8"?>
+<p:sld xmlns:a="http://schemas.openxmlformats.org/drawingml/2006/main" xmlns:r="http://schemas.openxmlformats.org/officeDocument/2006/relationships" xmlns:p="http://schemas.openxmlformats.org/presentationml/2006/main">
+  <p:cSld>
+    <p:spTree>
+      <p:nvGrpSpPr>
+        <p:cNvPr id="1" name=""/>
+        <p:cNvGrpSpPr/>
+        <p:nvPr/>
+      </p:nvGrpSpPr>
+      <p:grpSpPr>
+        <a:xfrm>
+          <a:off x="0" y="0"/>
+          <a:ext cx="0" cy="0"/>
+          <a:chOff x="0" y="0"/>
+          <a:chExt cx="0" cy="0"/>
+        </a:xfrm>
+      </p:grpSpPr>
+      <p:sp>
+        <p:nvSpPr>
+          <p:cNvPr id="2" name="Titre 1">
+            <a:extLst>
+              <a:ext uri="{FF2B5EF4-FFF2-40B4-BE49-F238E27FC236}">
+                <a16:creationId xmlns:a16="http://schemas.microsoft.com/office/drawing/2014/main" id="{55589F1D-A246-79CB-8F6D-9513EC545437}"/>
+              </a:ext>
+            </a:extLst>
+          </p:cNvPr>
+          <p:cNvSpPr>
+            <a:spLocks noGrp="1"/>
+          </p:cNvSpPr>
+          <p:nvPr>
+            <p:ph type="title"/>
+          </p:nvPr>
+        </p:nvSpPr>
+        <p:spPr/>
+        <p:txBody>
+          <a:bodyPr/>
+          <a:lstStyle/>
+          <a:p>
+            <a:endParaRPr lang="fr-FR"/>
+          </a:p>
+        </p:txBody>
+      </p:sp>
+      <p:sp>
+        <p:nvSpPr>
+          <p:cNvPr id="3" name="Espace réservé du contenu 2">
+            <a:extLst>
+              <a:ext uri="{FF2B5EF4-FFF2-40B4-BE49-F238E27FC236}">
+                <a16:creationId xmlns:a16="http://schemas.microsoft.com/office/drawing/2014/main" id="{12AA23CF-3276-8ED5-8D5E-E9EDD6361FD3}"/>
+              </a:ext>
+            </a:extLst>
+          </p:cNvPr>
+          <p:cNvSpPr>
+            <a:spLocks noGrp="1"/>
+          </p:cNvSpPr>
+          <p:nvPr>
+            <p:ph idx="1"/>
+          </p:nvPr>
+        </p:nvSpPr>
+        <p:spPr/>
+        <p:txBody>
+          <a:bodyPr/>
+          <a:lstStyle/>
+          <a:p>
+            <a:endParaRPr lang="fr-FR"/>
+          </a:p>
+        </p:txBody>
+      </p:sp>
+    </p:spTree>
+    <p:extLst>
+      <p:ext uri="{BB962C8B-B14F-4D97-AF65-F5344CB8AC3E}">
+        <p14:creationId xmlns:p14="http://schemas.microsoft.com/office/powerpoint/2010/main" val="1972986352"/>
+      </p:ext>
+    </p:extLst>
+  </p:cSld>
+  <p:clrMapOvr>
+    <a:masterClrMapping/>
+  </p:clrMapOvr>
+</p:sld>
+</file>
+
+<file path=ppt/slides/slide3.xml><?xml version="1.0" encoding="utf-8"?>
+<p:sld xmlns:a="http://schemas.openxmlformats.org/drawingml/2006/main" xmlns:r="http://schemas.openxmlformats.org/officeDocument/2006/relationships" xmlns:p="http://schemas.openxmlformats.org/presentationml/2006/main">
+  <p:cSld>
+    <p:spTree>
+      <p:nvGrpSpPr>
+        <p:cNvPr id="1" name=""/>
+        <p:cNvGrpSpPr/>
+        <p:nvPr/>
+      </p:nvGrpSpPr>
+      <p:grpSpPr>
+        <a:xfrm>
+          <a:off x="0" y="0"/>
+          <a:ext cx="0" cy="0"/>
+          <a:chOff x="0" y="0"/>
+          <a:chExt cx="0" cy="0"/>
+        </a:xfrm>
+      </p:grpSpPr>
+      <p:sp>
+        <p:nvSpPr>
+          <p:cNvPr id="2" name="Titre 1">
+            <a:extLst>
+              <a:ext uri="{FF2B5EF4-FFF2-40B4-BE49-F238E27FC236}">
+                <a16:creationId xmlns:a16="http://schemas.microsoft.com/office/drawing/2014/main" id="{EFFDD1AE-2DDB-8EA7-AFEC-9BB65EBD5B2E}"/>
+              </a:ext>
+            </a:extLst>
+          </p:cNvPr>
+          <p:cNvSpPr>
+            <a:spLocks noGrp="1"/>
+          </p:cNvSpPr>
+          <p:nvPr>
+            <p:ph type="title"/>
+          </p:nvPr>
+        </p:nvSpPr>
+        <p:spPr/>
+        <p:txBody>
+          <a:bodyPr/>
+          <a:lstStyle/>
+          <a:p>
+            <a:endParaRPr lang="fr-FR"/>
+          </a:p>
+        </p:txBody>
+      </p:sp>
+      <p:sp>
+        <p:nvSpPr>
+          <p:cNvPr id="3" name="Espace réservé du contenu 2">
+            <a:extLst>
+              <a:ext uri="{FF2B5EF4-FFF2-40B4-BE49-F238E27FC236}">
+                <a16:creationId xmlns:a16="http://schemas.microsoft.com/office/drawing/2014/main" id="{989203E8-A09C-5D51-4248-9ACC8D450434}"/>
+              </a:ext>
+            </a:extLst>
+          </p:cNvPr>
+          <p:cNvSpPr>
+            <a:spLocks noGrp="1"/>
+          </p:cNvSpPr>
+          <p:nvPr>
+            <p:ph idx="1"/>
+          </p:nvPr>
+        </p:nvSpPr>
+        <p:spPr/>
+        <p:txBody>
+          <a:bodyPr/>
+          <a:lstStyle/>
+          <a:p>
+            <a:endParaRPr lang="fr-FR"/>
+          </a:p>
+        </p:txBody>
+      </p:sp>
+    </p:spTree>
+    <p:extLst>
+      <p:ext uri="{BB962C8B-B14F-4D97-AF65-F5344CB8AC3E}">
+        <p14:creationId xmlns:p14="http://schemas.microsoft.com/office/powerpoint/2010/main" val="789833125"/>
+      </p:ext>
+    </p:extLst>
+  </p:cSld>
+  <p:clrMapOvr>
+    <a:masterClrMapping/>
+  </p:clrMapOvr>
+</p:sld>
+</file>
+
+<file path=ppt/slides/slide4.xml><?xml version="1.0" encoding="utf-8"?>
+<p:sld xmlns:a="http://schemas.openxmlformats.org/drawingml/2006/main" xmlns:r="http://schemas.openxmlformats.org/officeDocument/2006/relationships" xmlns:p="http://schemas.openxmlformats.org/presentationml/2006/main">
+  <p:cSld>
+    <p:spTree>
+      <p:nvGrpSpPr>
+        <p:cNvPr id="1" name=""/>
+        <p:cNvGrpSpPr/>
+        <p:nvPr/>
+      </p:nvGrpSpPr>
+      <p:grpSpPr>
+        <a:xfrm>
+          <a:off x="0" y="0"/>
+          <a:ext cx="0" cy="0"/>
+          <a:chOff x="0" y="0"/>
+          <a:chExt cx="0" cy="0"/>
+        </a:xfrm>
+      </p:grpSpPr>
+      <p:sp>
+        <p:nvSpPr>
+          <p:cNvPr id="2" name="Titre 1">
+            <a:extLst>
+              <a:ext uri="{FF2B5EF4-FFF2-40B4-BE49-F238E27FC236}">
+                <a16:creationId xmlns:a16="http://schemas.microsoft.com/office/drawing/2014/main" id="{1E9DC683-7A8A-B7EE-2FEE-67C04E3FC65D}"/>
+              </a:ext>
+            </a:extLst>
+          </p:cNvPr>
+          <p:cNvSpPr>
+            <a:spLocks noGrp="1"/>
+          </p:cNvSpPr>
+          <p:nvPr>
+            <p:ph type="title"/>
+          </p:nvPr>
+        </p:nvSpPr>
+        <p:spPr/>
+        <p:txBody>
+          <a:bodyPr/>
+          <a:lstStyle/>
+          <a:p>
+            <a:endParaRPr lang="fr-FR"/>
+          </a:p>
+        </p:txBody>
+      </p:sp>
+      <p:sp>
+        <p:nvSpPr>
+          <p:cNvPr id="3" name="Espace réservé du contenu 2">
+            <a:extLst>
+              <a:ext uri="{FF2B5EF4-FFF2-40B4-BE49-F238E27FC236}">
+                <a16:creationId xmlns:a16="http://schemas.microsoft.com/office/drawing/2014/main" id="{30F3B2C7-9BF6-16E5-1F62-DA8B1E781424}"/>
+              </a:ext>
+            </a:extLst>
+          </p:cNvPr>
+          <p:cNvSpPr>
+            <a:spLocks noGrp="1"/>
+          </p:cNvSpPr>
+          <p:nvPr>
+            <p:ph idx="1"/>
+          </p:nvPr>
+        </p:nvSpPr>
+        <p:spPr/>
+        <p:txBody>
+          <a:bodyPr/>
+          <a:lstStyle/>
+          <a:p>
+            <a:endParaRPr lang="fr-FR"/>
+          </a:p>
+        </p:txBody>
+      </p:sp>
+    </p:spTree>
+    <p:extLst>
+      <p:ext uri="{BB962C8B-B14F-4D97-AF65-F5344CB8AC3E}">
+        <p14:creationId xmlns:p14="http://schemas.microsoft.com/office/powerpoint/2010/main" val="1878146245"/>
+      </p:ext>
+    </p:extLst>
+  </p:cSld>
+  <p:clrMapOvr>
+    <a:masterClrMapping/>
+  </p:clrMapOvr>
+</p:sld>
+</file>
+
+<file path=ppt/slides/slide5.xml><?xml version="1.0" encoding="utf-8"?>
+<p:sld xmlns:a="http://schemas.openxmlformats.org/drawingml/2006/main" xmlns:r="http://schemas.openxmlformats.org/officeDocument/2006/relationships" xmlns:p="http://schemas.openxmlformats.org/presentationml/2006/main">
+  <p:cSld>
+    <p:spTree>
+      <p:nvGrpSpPr>
+        <p:cNvPr id="1" name=""/>
+        <p:cNvGrpSpPr/>
+        <p:nvPr/>
+      </p:nvGrpSpPr>
+      <p:grpSpPr>
+        <a:xfrm>
+          <a:off x="0" y="0"/>
+          <a:ext cx="0" cy="0"/>
+          <a:chOff x="0" y="0"/>
+          <a:chExt cx="0" cy="0"/>
+        </a:xfrm>
+      </p:grpSpPr>
+      <p:sp>
+        <p:nvSpPr>
+          <p:cNvPr id="2" name="Titre 1">
+            <a:extLst>
+              <a:ext uri="{FF2B5EF4-FFF2-40B4-BE49-F238E27FC236}">
+                <a16:creationId xmlns:a16="http://schemas.microsoft.com/office/drawing/2014/main" id="{14E86E37-5D2C-0BF6-676B-4D1BCEB1C272}"/>
+              </a:ext>
+            </a:extLst>
+          </p:cNvPr>
+          <p:cNvSpPr>
+            <a:spLocks noGrp="1"/>
+          </p:cNvSpPr>
+          <p:nvPr>
+            <p:ph type="title"/>
+          </p:nvPr>
+        </p:nvSpPr>
+        <p:spPr/>
+        <p:txBody>
+          <a:bodyPr/>
+          <a:lstStyle/>
+          <a:p>
+            <a:endParaRPr lang="fr-FR"/>
+          </a:p>
+        </p:txBody>
+      </p:sp>
+      <p:sp>
+        <p:nvSpPr>
+          <p:cNvPr id="3" name="Espace réservé du contenu 2">
+            <a:extLst>
+              <a:ext uri="{FF2B5EF4-FFF2-40B4-BE49-F238E27FC236}">
+                <a16:creationId xmlns:a16="http://schemas.microsoft.com/office/drawing/2014/main" id="{2B8EEF60-9E27-91D9-3463-4B63EB624953}"/>
+              </a:ext>
+            </a:extLst>
+          </p:cNvPr>
+          <p:cNvSpPr>
+            <a:spLocks noGrp="1"/>
+          </p:cNvSpPr>
+          <p:nvPr>
+            <p:ph idx="1"/>
+          </p:nvPr>
+        </p:nvSpPr>
+        <p:spPr/>
+        <p:txBody>
+          <a:bodyPr/>
+          <a:lstStyle/>
+          <a:p>
+            <a:endParaRPr lang="fr-FR" dirty="0"/>
+          </a:p>
+        </p:txBody>
+      </p:sp>
+    </p:spTree>
+    <p:extLst>
+      <p:ext uri="{BB962C8B-B14F-4D97-AF65-F5344CB8AC3E}">
+        <p14:creationId xmlns:p14="http://schemas.microsoft.com/office/powerpoint/2010/main" val="1504502749"/>
       </p:ext>
     </p:extLst>
   </p:cSld>

</xml_diff>